<commit_message>
Update presentations and guide with 3-dataset results (AUC 0.959)
</commit_message>
<xml_diff>
--- a/VKRDoc/Defense_Presentation_v2.pptx
+++ b/VKRDoc/Defense_Presentation_v2.pptx
@@ -4159,11 +4159,11 @@
               </a:defRPr>
             </a:pPr>
             <a:r>
-              <a:t>Обучение на одном датасете (DFDC subset)</a:t>
+              <a:t>Обучение выполнено на трёх датасетах (10023 видео)</a:t>
             </a:r>
             <a:br/>
             <a:r>
-              <a:t>Ограниченная cross-dataset evaluation (DFDC02 → DFD01)</a:t>
+              <a:t>Cross-dataset и multi-dataset evaluation выполнены</a:t>
             </a:r>
           </a:p>
           <a:p>
@@ -4178,7 +4178,7 @@
               </a:defRPr>
             </a:pPr>
             <a:r>
-              <a:t>Фиксированный T=16</a:t>
+              <a:t>Исследованы T=16 и T=32</a:t>
             </a:r>
             <a:br/>
             <a:r>
@@ -4216,11 +4216,11 @@
               </a:defRPr>
             </a:pPr>
             <a:r>
-              <a:t>Ограниченный объём данных</a:t>
+              <a:t>3 датасета, 3 метода генерации</a:t>
             </a:r>
             <a:br/>
             <a:r>
-              <a:t>(~3300 видео)</a:t>
+              <a:t>(DFDC02+DFD01+CelebDF)</a:t>
             </a:r>
           </a:p>
         </p:txBody>
@@ -4315,11 +4315,11 @@
               </a:defRPr>
             </a:pPr>
             <a:r>
-              <a:t>Расширение cross-dataset evaluation</a:t>
+              <a:t>Расширение на FaceForensics++</a:t>
             </a:r>
             <a:br/>
             <a:r>
-              <a:t>(FaceForensics++, Celeb-DF-v2, multi-dataset training)</a:t>
+              <a:t>(дополнительные датасеты и методы генерации)</a:t>
             </a:r>
           </a:p>
           <a:p>
@@ -4588,7 +4588,7 @@
               </a:defRPr>
             </a:pPr>
             <a:r>
-              <a:t>Достигнут AUC 0.9777 на DFDC subset (in-domain evaluation)</a:t>
+              <a:t>Достигнут AUC 0.959 на трёх датасетах (DFDC02+DFD01+CelebDF, 10023 видео)</a:t>
             </a:r>
           </a:p>
           <a:p>
@@ -4618,7 +4618,7 @@
               </a:defRPr>
             </a:pPr>
             <a:r>
-              <a:t>Temporal-only ветвь (AUC 0.9655) подтвердила frame differences как самостоятельный дискриминативный сигнал</a:t>
+              <a:t>Multi-dataset обучение повысило AUC с 0.899 (2 датасета) до 0.959 (3 датасета)</a:t>
             </a:r>
           </a:p>
           <a:p>

</xml_diff>